<commit_message>
added slides from Dirk, added QR code to point to StreamDevice documentation
</commit_message>
<xml_diff>
--- a/presentations/StreamDeviceIntro.pptx
+++ b/presentations/StreamDeviceIntro.pptx
@@ -48,14 +48,14 @@
     </p:embeddedFont>
     <p:embeddedFont>
       <p:font typeface="Oswald Regular" panose="02000503000000000000" pitchFamily="2" charset="77"/>
-      <p:regular r:id="rId26"/>
+      <p:regular r:id=""/>
     </p:embeddedFont>
     <p:embeddedFont>
       <p:font typeface="Source Sans Pro" panose="020B0503030403020204" pitchFamily="34" charset="0"/>
-      <p:regular r:id="rId27"/>
-      <p:bold r:id="rId28"/>
-      <p:italic r:id="rId29"/>
-      <p:boldItalic r:id="rId30"/>
+      <p:regular r:id="rId26"/>
+      <p:bold r:id="rId27"/>
+      <p:italic r:id="rId28"/>
+      <p:boldItalic r:id="rId29"/>
     </p:embeddedFont>
   </p:embeddedFontLst>
   <p:defaultTextStyle>
@@ -269,7 +269,7 @@
           <a:p>
             <a:fld id="{E00E58FE-3AE1-4995-80E6-8AF0F1DA0E4E}" type="datetimeFigureOut">
               <a:rPr lang="de-DE" smtClean="0"/>
-              <a:t>15.10.25</a:t>
+              <a:t>21.04.26</a:t>
             </a:fld>
             <a:endParaRPr lang="de-DE"/>
           </a:p>
@@ -446,7 +446,7 @@
           <a:p>
             <a:fld id="{45091381-FB9B-4B1C-99E3-890DFD4525D3}" type="datetimeFigureOut">
               <a:rPr lang="de-DE" smtClean="0"/>
-              <a:t>15.10.25</a:t>
+              <a:t>21.04.26</a:t>
             </a:fld>
             <a:endParaRPr lang="de-DE"/>
           </a:p>
@@ -973,7 +973,7 @@
           <a:p>
             <a:fld id="{77B9AAF2-2243-4209-A85C-F7036AF186DC}" type="datetimeFigureOut">
               <a:rPr lang="de-DE" smtClean="0"/>
-              <a:t>15.10.25</a:t>
+              <a:t>21.04.26</a:t>
             </a:fld>
             <a:endParaRPr lang="de-DE"/>
           </a:p>
@@ -1213,7 +1213,7 @@
           <a:p>
             <a:fld id="{77B9AAF2-2243-4209-A85C-F7036AF186DC}" type="datetimeFigureOut">
               <a:rPr lang="de-DE" smtClean="0"/>
-              <a:t>15.10.25</a:t>
+              <a:t>21.04.26</a:t>
             </a:fld>
             <a:endParaRPr lang="de-DE"/>
           </a:p>
@@ -1453,7 +1453,7 @@
           <a:p>
             <a:fld id="{77B9AAF2-2243-4209-A85C-F7036AF186DC}" type="datetimeFigureOut">
               <a:rPr lang="de-DE" smtClean="0"/>
-              <a:t>15.10.25</a:t>
+              <a:t>21.04.26</a:t>
             </a:fld>
             <a:endParaRPr lang="de-DE"/>
           </a:p>
@@ -1693,7 +1693,7 @@
           <a:p>
             <a:fld id="{77B9AAF2-2243-4209-A85C-F7036AF186DC}" type="datetimeFigureOut">
               <a:rPr lang="de-DE" smtClean="0"/>
-              <a:t>15.10.25</a:t>
+              <a:t>21.04.26</a:t>
             </a:fld>
             <a:endParaRPr lang="de-DE"/>
           </a:p>
@@ -1999,7 +1999,7 @@
           <a:p>
             <a:fld id="{77B9AAF2-2243-4209-A85C-F7036AF186DC}" type="datetimeFigureOut">
               <a:rPr lang="de-DE" smtClean="0"/>
-              <a:t>15.10.25</a:t>
+              <a:t>21.04.26</a:t>
             </a:fld>
             <a:endParaRPr lang="de-DE"/>
           </a:p>
@@ -2305,7 +2305,7 @@
           <a:p>
             <a:fld id="{77B9AAF2-2243-4209-A85C-F7036AF186DC}" type="datetimeFigureOut">
               <a:rPr lang="de-DE" smtClean="0"/>
-              <a:t>15.10.25</a:t>
+              <a:t>21.04.26</a:t>
             </a:fld>
             <a:endParaRPr lang="de-DE"/>
           </a:p>
@@ -2759,7 +2759,7 @@
           <a:p>
             <a:fld id="{77B9AAF2-2243-4209-A85C-F7036AF186DC}" type="datetimeFigureOut">
               <a:rPr lang="de-DE" smtClean="0"/>
-              <a:t>15.10.25</a:t>
+              <a:t>21.04.26</a:t>
             </a:fld>
             <a:endParaRPr lang="de-DE"/>
           </a:p>
@@ -2933,7 +2933,7 @@
           <a:p>
             <a:fld id="{77B9AAF2-2243-4209-A85C-F7036AF186DC}" type="datetimeFigureOut">
               <a:rPr lang="de-DE" smtClean="0"/>
-              <a:t>15.10.25</a:t>
+              <a:t>21.04.26</a:t>
             </a:fld>
             <a:endParaRPr lang="de-DE"/>
           </a:p>
@@ -3309,7 +3309,7 @@
           <a:p>
             <a:fld id="{77B9AAF2-2243-4209-A85C-F7036AF186DC}" type="datetimeFigureOut">
               <a:rPr lang="de-DE" smtClean="0"/>
-              <a:t>15.10.25</a:t>
+              <a:t>21.04.26</a:t>
             </a:fld>
             <a:endParaRPr lang="de-DE"/>
           </a:p>
@@ -3635,7 +3635,7 @@
           <a:p>
             <a:fld id="{77B9AAF2-2243-4209-A85C-F7036AF186DC}" type="datetimeFigureOut">
               <a:rPr lang="de-DE" smtClean="0"/>
-              <a:t>15.10.25</a:t>
+              <a:t>21.04.26</a:t>
             </a:fld>
             <a:endParaRPr lang="de-DE"/>
           </a:p>
@@ -5265,6 +5265,42 @@
           </a:p>
         </p:txBody>
       </p:sp>
+      <p:pic>
+        <p:nvPicPr>
+          <p:cNvPr id="5" name="Picture 4">
+            <a:extLst>
+              <a:ext uri="{FF2B5EF4-FFF2-40B4-BE49-F238E27FC236}">
+                <a16:creationId xmlns:a16="http://schemas.microsoft.com/office/drawing/2014/main" id="{87D7AE0E-1327-45FF-4DF6-AC755DF77471}"/>
+              </a:ext>
+            </a:extLst>
+          </p:cNvPr>
+          <p:cNvPicPr>
+            <a:picLocks noChangeAspect="1"/>
+          </p:cNvPicPr>
+          <p:nvPr/>
+        </p:nvPicPr>
+        <p:blipFill>
+          <a:blip r:embed="rId3">
+            <a:extLst>
+              <a:ext uri="{28A0092B-C50C-407E-A947-70E740481C1C}">
+                <a14:useLocalDpi xmlns:a14="http://schemas.microsoft.com/office/drawing/2010/main" val="0"/>
+              </a:ext>
+            </a:extLst>
+          </a:blip>
+          <a:stretch>
+            <a:fillRect/>
+          </a:stretch>
+        </p:blipFill>
+        <p:spPr>
+          <a:xfrm>
+            <a:off x="10444047" y="4649504"/>
+            <a:ext cx="1308242" cy="1308242"/>
+          </a:xfrm>
+          <a:prstGeom prst="rect">
+            <a:avLst/>
+          </a:prstGeom>
+        </p:spPr>
+      </p:pic>
     </p:spTree>
     <p:extLst>
       <p:ext uri="{BB962C8B-B14F-4D97-AF65-F5344CB8AC3E}">

</xml_diff>